<commit_message>
Add RRW calculation requests and updated research handoff
</commit_message>
<xml_diff>
--- a/汇报文件/RRW研究进度汇报_2026-09-15.pptx
+++ b/汇报文件/RRW研究进度汇报_2026-09-15.pptx
@@ -2026,7 +2026,7 @@
           </a:bodyPr>
           <a:lstStyle/>
           <a:p>
-            <a:pPr>
+            <a:pPr algn="ctr">
               <a:defRPr sz="3300" b="1">
                 <a:solidFill>
                   <a:srgbClr val="17324D"/>
@@ -2085,7 +2085,7 @@
           </a:bodyPr>
           <a:lstStyle/>
           <a:p>
-            <a:pPr>
+            <a:pPr algn="ctr">
               <a:defRPr sz="4200" b="1">
                 <a:solidFill>
                   <a:srgbClr val="17324D"/>
@@ -2104,7 +2104,7 @@
                 <a:ea typeface="微软雅黑" panose="020B0503020204020204" charset="-122"/>
                 <a:cs typeface="微软雅黑" panose="020B0503020204020204" charset="-122"/>
               </a:rPr>
-              <a:t>RRW 研究进度汇报</a:t>
+              <a:t>研究进度汇报</a:t>
             </a:r>
             <a:endParaRPr sz="4200" b="1">
               <a:solidFill>
@@ -2163,7 +2163,29 @@
                 <a:ea typeface="微软雅黑" panose="020B0503020204020204" charset="-122"/>
                 <a:cs typeface="微软雅黑" panose="020B0503020204020204" charset="-122"/>
               </a:rPr>
-              <a:t>已完成 RAW 主要复现，下一步开展 RRW 基准计算</a:t>
+              <a:t>已完成 </a:t>
+            </a:r>
+            <a:r>
+              <a:rPr lang="zh-CN" sz="2175" b="0">
+                <a:solidFill>
+                  <a:srgbClr val="276EA8"/>
+                </a:solidFill>
+                <a:latin typeface="微软雅黑" panose="020B0503020204020204" charset="-122"/>
+                <a:ea typeface="微软雅黑" panose="020B0503020204020204" charset="-122"/>
+                <a:cs typeface="微软雅黑" panose="020B0503020204020204" charset="-122"/>
+              </a:rPr>
+              <a:t>串联系统下单参数与多参数</a:t>
+            </a:r>
+            <a:r>
+              <a:rPr sz="2175" b="0">
+                <a:solidFill>
+                  <a:srgbClr val="276EA8"/>
+                </a:solidFill>
+                <a:latin typeface="微软雅黑" panose="020B0503020204020204" charset="-122"/>
+                <a:ea typeface="微软雅黑" panose="020B0503020204020204" charset="-122"/>
+                <a:cs typeface="微软雅黑" panose="020B0503020204020204" charset="-122"/>
+              </a:rPr>
+              <a:t>RAW 主要复现，下一步开展 RRW 基准计算</a:t>
             </a:r>
             <a:endParaRPr sz="2175" b="0">
               <a:solidFill>
@@ -6185,37 +6207,6 @@
                 <a:ea typeface="微软雅黑" panose="020B0503020204020204" charset="-122"/>
                 <a:cs typeface="微软雅黑" panose="020B0503020204020204" charset="-122"/>
               </a:rPr>
-              <a:t>完全可靠的实现与失效定义、RRW区间口径。</a:t>
-            </a:r>
-            <a:endParaRPr sz="2250" b="1">
-              <a:solidFill>
-                <a:srgbClr val="276EA8"/>
-              </a:solidFill>
-              <a:latin typeface="微软雅黑" panose="020B0503020204020204" charset="-122"/>
-              <a:ea typeface="微软雅黑" panose="020B0503020204020204" charset="-122"/>
-              <a:cs typeface="微软雅黑" panose="020B0503020204020204" charset="-122"/>
-            </a:endParaRPr>
-          </a:p>
-          <a:p>
-            <a:pPr>
-              <a:defRPr sz="2250" b="1">
-                <a:solidFill>
-                  <a:srgbClr val="276EA8"/>
-                </a:solidFill>
-                <a:latin typeface="微软雅黑" panose="020B0503020204020204" charset="-122"/>
-                <a:ea typeface="微软雅黑" panose="020B0503020204020204" charset="-122"/>
-                <a:cs typeface="微软雅黑" panose="020B0503020204020204" charset="-122"/>
-              </a:defRPr>
-            </a:pPr>
-            <a:r>
-              <a:rPr sz="2250" b="1">
-                <a:solidFill>
-                  <a:srgbClr val="276EA8"/>
-                </a:solidFill>
-                <a:latin typeface="微软雅黑" panose="020B0503020204020204" charset="-122"/>
-                <a:ea typeface="微软雅黑" panose="020B0503020204020204" charset="-122"/>
-                <a:cs typeface="微软雅黑" panose="020B0503020204020204" charset="-122"/>
-              </a:rPr>
               <a:t>申请首组基准计算，并明确返回数据项。</a:t>
             </a:r>
             <a:endParaRPr sz="2250" b="1">

</xml_diff>